<commit_message>
Update project presentation with live website link
</commit_message>
<xml_diff>
--- a/docs/AI_Mechanical_Safety_Compliance_Advisor_ProjectPresentation.pptx
+++ b/docs/AI_Mechanical_Safety_Compliance_Advisor_ProjectPresentation.pptx
@@ -261,8 +261,11 @@
     </a:lvl9pPr>
   </p:defaultTextStyle>
   <p:extLst>
+    <p:ext uri="{EFAFB233-063F-42B5-8137-9DF3F51BA10A}">
+      <p15:sldGuideLst xmlns:p15="http://schemas.microsoft.com/office/powerpoint/2012/main"/>
+    </p:ext>
     <p:ext uri="GoogleSlidesCustomDataVersion2">
-      <go:slidesCustomData xmlns:go="http://customooxmlschemas.google.com/" xmlns:ahyp="http://schemas.microsoft.com/office/drawing/2018/hyperlinkcolor" xmlns:p15="http://schemas.microsoft.com/office/powerpoint/2012/main" xmlns:p14="http://schemas.microsoft.com/office/powerpoint/2010/main" xmlns:com="http://schemas.openxmlformats.org/drawingml/2006/compatibility" xmlns:pvml="urn:schemas-microsoft-com:office:powerpoint" xmlns:v="urn:schemas-microsoft-com:vml" xmlns:o="urn:schemas-microsoft-com:office:office" xmlns:dgm="http://schemas.openxmlformats.org/drawingml/2006/diagram" xmlns:c="http://schemas.openxmlformats.org/drawingml/2006/chart" xmlns:mv="urn:schemas-microsoft-com:mac:vml" xmlns:mc="http://schemas.openxmlformats.org/markup-compatibility/2006" xmlns="" r:id="rId27" roundtripDataSignature="AMtx7mjt3491jQ7aCoyIz2WXeHKroE7tpQ=="/>
+      <go:slidesCustomData xmlns="" xmlns:mc="http://schemas.openxmlformats.org/markup-compatibility/2006" xmlns:mv="urn:schemas-microsoft-com:mac:vml" xmlns:c="http://schemas.openxmlformats.org/drawingml/2006/chart" xmlns:dgm="http://schemas.openxmlformats.org/drawingml/2006/diagram" xmlns:o="urn:schemas-microsoft-com:office:office" xmlns:v="urn:schemas-microsoft-com:vml" xmlns:pvml="urn:schemas-microsoft-com:office:powerpoint" xmlns:com="http://schemas.openxmlformats.org/drawingml/2006/compatibility" xmlns:p14="http://schemas.microsoft.com/office/powerpoint/2010/main" xmlns:p15="http://schemas.microsoft.com/office/powerpoint/2012/main" xmlns:ahyp="http://schemas.microsoft.com/office/drawing/2018/hyperlinkcolor" xmlns:go="http://customooxmlschemas.google.com/" r:id="rId27" roundtripDataSignature="AMtx7mjt3491jQ7aCoyIz2WXeHKroE7tpQ=="/>
     </p:ext>
   </p:extLst>
 </p:presentation>
@@ -271,9 +274,38 @@
 <file path=ppt/revisionInfo.xml><?xml version="1.0" encoding="utf-8"?>
 <p1510:revInfo xmlns:a="http://schemas.openxmlformats.org/drawingml/2006/main" xmlns:r="http://schemas.openxmlformats.org/officeDocument/2006/relationships" xmlns:p1510="http://schemas.microsoft.com/office/powerpoint/2015/10/main">
   <p1510:revLst>
-    <p1510:client id="{5597DED7-87E9-8FFE-C42B-07F44890EE69}" v="36" dt="2026-07-14T12:42:56.737"/>
+    <p1510:client id="{F8A9B8A3-308F-4602-8A10-A385946EEED5}" v="3" dt="2026-09-23T16:38:11.266"/>
   </p1510:revLst>
 </p1510:revInfo>
+</file>
+
+<file path=ppt/changesInfos/changesInfo1.xml><?xml version="1.0" encoding="utf-8"?>
+<pc:chgInfo xmlns:a="http://schemas.openxmlformats.org/drawingml/2006/main" xmlns:r="http://schemas.openxmlformats.org/officeDocument/2006/relationships" xmlns:ac="http://schemas.microsoft.com/office/drawing/2013/main/command" xmlns:pc="http://schemas.microsoft.com/office/powerpoint/2013/main/command">
+  <pc:docChgLst>
+    <pc:chgData name="basavakumar.in@gmail.com" userId="798ece908ce1efad" providerId="LiveId" clId="{3C5E7F4C-E2B4-4338-9DC1-D455DF6C8446}"/>
+    <pc:docChg chg="modSld">
+      <pc:chgData name="basavakumar.in@gmail.com" userId="798ece908ce1efad" providerId="LiveId" clId="{3C5E7F4C-E2B4-4338-9DC1-D455DF6C8446}" dt="2026-09-23T16:38:16.077" v="6" actId="20577"/>
+      <pc:docMkLst>
+        <pc:docMk/>
+      </pc:docMkLst>
+      <pc:sldChg chg="modSp mod">
+        <pc:chgData name="basavakumar.in@gmail.com" userId="798ece908ce1efad" providerId="LiveId" clId="{3C5E7F4C-E2B4-4338-9DC1-D455DF6C8446}" dt="2026-09-23T16:38:16.077" v="6" actId="20577"/>
+        <pc:sldMkLst>
+          <pc:docMk/>
+          <pc:sldMk cId="4040412275" sldId="305"/>
+        </pc:sldMkLst>
+        <pc:spChg chg="mod">
+          <ac:chgData name="basavakumar.in@gmail.com" userId="798ece908ce1efad" providerId="LiveId" clId="{3C5E7F4C-E2B4-4338-9DC1-D455DF6C8446}" dt="2026-09-23T16:38:16.077" v="6" actId="20577"/>
+          <ac:spMkLst>
+            <pc:docMk/>
+            <pc:sldMk cId="4040412275" sldId="305"/>
+            <ac:spMk id="279" creationId="{3711AF54-94A6-B837-31EF-9A8C4ECB9AF6}"/>
+          </ac:spMkLst>
+        </pc:spChg>
+      </pc:sldChg>
+    </pc:docChg>
+  </pc:docChgLst>
+</pc:chgInfo>
 </file>
 
 <file path=ppt/notesMasters/notesMaster1.xml><?xml version="1.0" encoding="utf-8"?>
@@ -14915,7 +14947,99 @@
                 </a:solidFill>
                 <a:hlinkClick r:id="rId3"/>
               </a:rPr>
-              <a:t>🔗 https://github.com/Anusha-Gangoor/AI-Mechanical-Safety-Compliance-Advisor</a:t>
+              <a:t>🔗 </a:t>
+            </a:r>
+            <a:r>
+              <a:rPr lang="en-IN" sz="1700" dirty="0">
+                <a:solidFill>
+                  <a:srgbClr val="1E1E1E"/>
+                </a:solidFill>
+                <a:hlinkClick r:id="rId3"/>
+              </a:rPr>
+              <a:t>https://github.com/Anusha-Gangoor/AI-Mechanical-Safety-Compliance-Advisor</a:t>
+            </a:r>
+            <a:endParaRPr lang="en-IN" sz="1700" dirty="0">
+              <a:solidFill>
+                <a:srgbClr val="1E1E1E"/>
+              </a:solidFill>
+            </a:endParaRPr>
+          </a:p>
+          <a:p>
+            <a:pPr lvl="0">
+              <a:buClr>
+                <a:srgbClr val="2B3541"/>
+              </a:buClr>
+              <a:buSzPts val="1850"/>
+              <a:defRPr sz="1700" b="0">
+                <a:solidFill>
+                  <a:srgbClr val="1E1E1E"/>
+                </a:solidFill>
+                <a:latin typeface="Arial"/>
+              </a:defRPr>
+            </a:pPr>
+            <a:endParaRPr lang="en-IN" sz="1700" dirty="0">
+              <a:solidFill>
+                <a:srgbClr val="1E1E1E"/>
+              </a:solidFill>
+            </a:endParaRPr>
+          </a:p>
+          <a:p>
+            <a:pPr lvl="0">
+              <a:buClr>
+                <a:srgbClr val="2B3541"/>
+              </a:buClr>
+              <a:buSzPts val="1850"/>
+              <a:defRPr sz="1700" b="0">
+                <a:solidFill>
+                  <a:srgbClr val="1E1E1E"/>
+                </a:solidFill>
+                <a:latin typeface="Arial"/>
+              </a:defRPr>
+            </a:pPr>
+            <a:r>
+              <a:rPr lang="en-IN" sz="1700" b="1" dirty="0">
+                <a:solidFill>
+                  <a:srgbClr val="1E1E1E"/>
+                </a:solidFill>
+              </a:rPr>
+              <a:t>Live Project Website</a:t>
+            </a:r>
+            <a:endParaRPr lang="en-IN" sz="1700" dirty="0">
+              <a:solidFill>
+                <a:srgbClr val="1E1E1E"/>
+              </a:solidFill>
+            </a:endParaRPr>
+          </a:p>
+          <a:p>
+            <a:pPr lvl="0">
+              <a:buClr>
+                <a:srgbClr val="2B3541"/>
+              </a:buClr>
+              <a:buSzPts val="1850"/>
+              <a:defRPr sz="1700" b="0">
+                <a:solidFill>
+                  <a:srgbClr val="1E1E1E"/>
+                </a:solidFill>
+                <a:latin typeface="Arial"/>
+              </a:defRPr>
+            </a:pPr>
+            <a:r>
+              <a:rPr lang="en-IN" sz="1700" dirty="0">
+                <a:solidFill>
+                  <a:srgbClr val="1E1E1E"/>
+                </a:solidFill>
+                <a:hlinkClick r:id="rId4"/>
+              </a:rPr>
+              <a:t>AI Mechanical Safety Advisor · </a:t>
+            </a:r>
+            <a:r>
+              <a:rPr lang="en-IN" sz="1700" dirty="0" err="1">
+                <a:solidFill>
+                  <a:srgbClr val="1E1E1E"/>
+                </a:solidFill>
+                <a:hlinkClick r:id="rId4"/>
+              </a:rPr>
+              <a:t>Streamlit</a:t>
             </a:r>
             <a:endParaRPr dirty="0"/>
           </a:p>

</xml_diff>